<commit_message>
Deck: 364 operating days/year (open year-round)
Operating days 320 -> 364 across the ROI math: gross misallocation
removed rises to ~$326k/yr, captured range to $98k-$163k/yr; payback
chart recomputed (mid-case break-even ~month 14, conservative ~month
23); assumption row now reads "364 - open year-round".

Co-Authored-By: Claude Opus 5 <noreply@anthropic.com>
Claude-Session: https://claude.ai/code/session_01LD5yKsRrn4hdVkKBX8VPbo
</commit_message>
<xml_diff>
--- a/docs/deck/attendance-forecast-roi.pptx
+++ b/docs/deck/attendance-forecast-roi.pptx
@@ -238,19 +238,19 @@
                   <c:v>-50</c:v>
                 </c:pt>
                 <c:pt idx="2">
-                  <c:v>-25</c:v>
+                  <c:v>-21</c:v>
                 </c:pt>
                 <c:pt idx="3">
-                  <c:v>24</c:v>
+                  <c:v>36</c:v>
                 </c:pt>
                 <c:pt idx="4">
-                  <c:v>73</c:v>
+                  <c:v>93</c:v>
                 </c:pt>
                 <c:pt idx="5">
-                  <c:v>122</c:v>
+                  <c:v>150</c:v>
                 </c:pt>
                 <c:pt idx="6">
-                  <c:v>172</c:v>
+                  <c:v>207</c:v>
                 </c:pt>
               </c:numCache>
             </c:numRef>
@@ -370,19 +370,19 @@
                   <c:v>-50</c:v>
                 </c:pt>
                 <c:pt idx="2">
-                  <c:v>-41</c:v>
+                  <c:v>-39</c:v>
                 </c:pt>
                 <c:pt idx="3">
-                  <c:v>-24</c:v>
+                  <c:v>-18</c:v>
                 </c:pt>
                 <c:pt idx="4">
-                  <c:v>-6</c:v>
+                  <c:v>3</c:v>
                 </c:pt>
                 <c:pt idx="5">
-                  <c:v>12</c:v>
+                  <c:v>24</c:v>
                 </c:pt>
                 <c:pt idx="6">
-                  <c:v>29</c:v>
+                  <c:v>45</c:v>
                 </c:pt>
               </c:numCache>
             </c:numRef>
@@ -3101,7 +3101,7 @@
                 <a:ea typeface="Cambria" pitchFamily="34" charset="-122"/>
                 <a:cs typeface="Cambria" pitchFamily="34" charset="-120"/>
               </a:rPr>
-              <a:t>Halving the miss: ~$86k–$143k a year.</a:t>
+              <a:t>Halving the miss: ~$98k–$163k a year.</a:t>
             </a:r>
             <a:endParaRPr lang="en-US" sz="3400" dirty="0"/>
           </a:p>
@@ -4456,7 +4456,7 @@
                           <a:ea typeface="Calibri" pitchFamily="34" charset="-122"/>
                           <a:cs typeface="Calibri" pitchFamily="34" charset="-120"/>
                         </a:rPr>
-                        <a:t>320</a:t>
+                        <a:t>364</a:t>
                       </a:r>
                       <a:endParaRPr lang="en-US" sz="1150" dirty="0">
                         <a:latin typeface="Calibri" charset="0"/>
@@ -4524,7 +4524,7 @@
                           <a:ea typeface="Calibri" pitchFamily="34" charset="-122"/>
                           <a:cs typeface="Calibri" pitchFamily="34" charset="-120"/>
                         </a:rPr>
-                        <a:t>our calendar</a:t>
+                        <a:t>open year-round</a:t>
                       </a:r>
                       <a:endParaRPr lang="en-US" sz="1150" dirty="0">
                         <a:latin typeface="Calibri" charset="0"/>
@@ -5259,7 +5259,7 @@
                 <a:ea typeface="Calibri" pitchFamily="34" charset="-122"/>
                 <a:cs typeface="Calibri" pitchFamily="34" charset="-120"/>
               </a:rPr>
-              <a:t>~$286k / yr</a:t>
+              <a:t>~$326k / yr</a:t>
             </a:r>
             <a:endParaRPr lang="en-US" sz="2200" dirty="0"/>
           </a:p>
@@ -5298,7 +5298,7 @@
                 <a:ea typeface="Calibri" pitchFamily="34" charset="-122"/>
                 <a:cs typeface="Calibri" pitchFamily="34" charset="-120"/>
               </a:rPr>
-              <a:t>gross misallocation removed (× 320 days)</a:t>
+              <a:t>gross misallocation removed (× 364 days)</a:t>
             </a:r>
             <a:endParaRPr lang="en-US" sz="1150" dirty="0"/>
           </a:p>
@@ -5359,7 +5359,7 @@
                 <a:ea typeface="Calibri" pitchFamily="34" charset="-122"/>
                 <a:cs typeface="Calibri" pitchFamily="34" charset="-120"/>
               </a:rPr>
-              <a:t>$86k–$143k / yr</a:t>
+              <a:t>$98k–$163k / yr</a:t>
             </a:r>
             <a:endParaRPr lang="en-US" sz="3000" dirty="0"/>
           </a:p>
@@ -5600,7 +5600,7 @@
                 <a:ea typeface="Cambria" pitchFamily="34" charset="-122"/>
                 <a:cs typeface="Cambria" pitchFamily="34" charset="-120"/>
               </a:rPr>
-              <a:t>Break-even ~month 15 in the mid case.</a:t>
+              <a:t>Break-even ~month 14 in the mid case.</a:t>
             </a:r>
             <a:endParaRPr lang="en-US" sz="3400" dirty="0"/>
           </a:p>
@@ -5877,7 +5877,7 @@
                 <a:ea typeface="Calibri" pitchFamily="34" charset="-122"/>
                 <a:cs typeface="Calibri" pitchFamily="34" charset="-120"/>
               </a:rPr>
-              <a:t>Break-even ~month 15</a:t>
+              <a:t>Break-even ~month 14</a:t>
             </a:r>
             <a:endParaRPr lang="en-US" sz="1400" dirty="0"/>
           </a:p>
@@ -5916,7 +5916,7 @@
                 <a:ea typeface="Calibri" pitchFamily="34" charset="-122"/>
                 <a:cs typeface="Calibri" pitchFamily="34" charset="-120"/>
               </a:rPr>
-              <a:t>mid case (~$114k/yr captured, net of run cost)</a:t>
+              <a:t>mid case (~$130k/yr captured, net of run cost)</a:t>
             </a:r>
             <a:endParaRPr lang="en-US" sz="1050" dirty="0"/>
           </a:p>
@@ -6016,7 +6016,7 @@
                 <a:ea typeface="Calibri" pitchFamily="34" charset="-122"/>
                 <a:cs typeface="Calibri" pitchFamily="34" charset="-120"/>
               </a:rPr>
-              <a:t>~month 26 if the model only closes a third of the gap — and if it can't beat 947 at all, Phase 0 kills it for ~$8k, not $50k</a:t>
+              <a:t>~month 23 if the model only closes a third of the gap — and if it can't beat 947 at all, Phase 0 kills it for ~$8k, not $50k</a:t>
             </a:r>
             <a:endParaRPr lang="en-US" sz="1050" dirty="0"/>
           </a:p>
@@ -8584,7 +8584,7 @@
                 <a:ea typeface="Calibri" pitchFamily="34" charset="-122"/>
                 <a:cs typeface="Calibri" pitchFamily="34" charset="-120"/>
               </a:rPr>
-              <a:t>Benefits start ~month 9; mid-case break-even lands mid-year-2. If Phase 0 says the 450 target is fantasy, we stop at the kill point having spent engineering time only.</a:t>
+              <a:t>Benefits start ~month 9; mid-case break-even lands early in year 2. If Phase 0 says the 450 target is fantasy, we stop at the kill point having spent engineering time only.</a:t>
             </a:r>
             <a:endParaRPr lang="en-US" sz="1250" dirty="0"/>
           </a:p>

</xml_diff>